<commit_message>
update dash analise fundamentalista
</commit_message>
<xml_diff>
--- a/Analise Fundamentalista/Imagens/Apresentação1.pptx
+++ b/Analise Fundamentalista/Imagens/Apresentação1.pptx
@@ -272,7 +272,7 @@
           <a:p>
             <a:fld id="{8926AEC2-7D35-43DD-9559-5900D89D553B}" type="datetimeFigureOut">
               <a:rPr lang="pt-BR" smtClean="0"/>
-              <a:t>16/09/2022</a:t>
+              <a:t>20/09/2022</a:t>
             </a:fld>
             <a:endParaRPr lang="pt-BR"/>
           </a:p>
@@ -470,7 +470,7 @@
           <a:p>
             <a:fld id="{8926AEC2-7D35-43DD-9559-5900D89D553B}" type="datetimeFigureOut">
               <a:rPr lang="pt-BR" smtClean="0"/>
-              <a:t>16/09/2022</a:t>
+              <a:t>20/09/2022</a:t>
             </a:fld>
             <a:endParaRPr lang="pt-BR"/>
           </a:p>
@@ -678,7 +678,7 @@
           <a:p>
             <a:fld id="{8926AEC2-7D35-43DD-9559-5900D89D553B}" type="datetimeFigureOut">
               <a:rPr lang="pt-BR" smtClean="0"/>
-              <a:t>16/09/2022</a:t>
+              <a:t>20/09/2022</a:t>
             </a:fld>
             <a:endParaRPr lang="pt-BR"/>
           </a:p>
@@ -876,7 +876,7 @@
           <a:p>
             <a:fld id="{8926AEC2-7D35-43DD-9559-5900D89D553B}" type="datetimeFigureOut">
               <a:rPr lang="pt-BR" smtClean="0"/>
-              <a:t>16/09/2022</a:t>
+              <a:t>20/09/2022</a:t>
             </a:fld>
             <a:endParaRPr lang="pt-BR"/>
           </a:p>
@@ -1151,7 +1151,7 @@
           <a:p>
             <a:fld id="{8926AEC2-7D35-43DD-9559-5900D89D553B}" type="datetimeFigureOut">
               <a:rPr lang="pt-BR" smtClean="0"/>
-              <a:t>16/09/2022</a:t>
+              <a:t>20/09/2022</a:t>
             </a:fld>
             <a:endParaRPr lang="pt-BR"/>
           </a:p>
@@ -1416,7 +1416,7 @@
           <a:p>
             <a:fld id="{8926AEC2-7D35-43DD-9559-5900D89D553B}" type="datetimeFigureOut">
               <a:rPr lang="pt-BR" smtClean="0"/>
-              <a:t>16/09/2022</a:t>
+              <a:t>20/09/2022</a:t>
             </a:fld>
             <a:endParaRPr lang="pt-BR"/>
           </a:p>
@@ -1828,7 +1828,7 @@
           <a:p>
             <a:fld id="{8926AEC2-7D35-43DD-9559-5900D89D553B}" type="datetimeFigureOut">
               <a:rPr lang="pt-BR" smtClean="0"/>
-              <a:t>16/09/2022</a:t>
+              <a:t>20/09/2022</a:t>
             </a:fld>
             <a:endParaRPr lang="pt-BR"/>
           </a:p>
@@ -1969,7 +1969,7 @@
           <a:p>
             <a:fld id="{8926AEC2-7D35-43DD-9559-5900D89D553B}" type="datetimeFigureOut">
               <a:rPr lang="pt-BR" smtClean="0"/>
-              <a:t>16/09/2022</a:t>
+              <a:t>20/09/2022</a:t>
             </a:fld>
             <a:endParaRPr lang="pt-BR"/>
           </a:p>
@@ -2082,7 +2082,7 @@
           <a:p>
             <a:fld id="{8926AEC2-7D35-43DD-9559-5900D89D553B}" type="datetimeFigureOut">
               <a:rPr lang="pt-BR" smtClean="0"/>
-              <a:t>16/09/2022</a:t>
+              <a:t>20/09/2022</a:t>
             </a:fld>
             <a:endParaRPr lang="pt-BR"/>
           </a:p>
@@ -2393,7 +2393,7 @@
           <a:p>
             <a:fld id="{8926AEC2-7D35-43DD-9559-5900D89D553B}" type="datetimeFigureOut">
               <a:rPr lang="pt-BR" smtClean="0"/>
-              <a:t>16/09/2022</a:t>
+              <a:t>20/09/2022</a:t>
             </a:fld>
             <a:endParaRPr lang="pt-BR"/>
           </a:p>
@@ -2681,7 +2681,7 @@
           <a:p>
             <a:fld id="{8926AEC2-7D35-43DD-9559-5900D89D553B}" type="datetimeFigureOut">
               <a:rPr lang="pt-BR" smtClean="0"/>
-              <a:t>16/09/2022</a:t>
+              <a:t>20/09/2022</a:t>
             </a:fld>
             <a:endParaRPr lang="pt-BR"/>
           </a:p>
@@ -2922,7 +2922,7 @@
           <a:p>
             <a:fld id="{8926AEC2-7D35-43DD-9559-5900D89D553B}" type="datetimeFigureOut">
               <a:rPr lang="pt-BR" smtClean="0"/>
-              <a:t>16/09/2022</a:t>
+              <a:t>20/09/2022</a:t>
             </a:fld>
             <a:endParaRPr lang="pt-BR"/>
           </a:p>
@@ -3940,6 +3940,78 @@
           <a:xfrm>
             <a:off x="238171" y="462800"/>
             <a:ext cx="1357648" cy="950354"/>
+          </a:xfrm>
+          <a:prstGeom prst="rect">
+            <a:avLst/>
+          </a:prstGeom>
+        </p:spPr>
+      </p:pic>
+      <p:pic>
+        <p:nvPicPr>
+          <p:cNvPr id="9" name="Imagem 8">
+            <a:extLst>
+              <a:ext uri="{FF2B5EF4-FFF2-40B4-BE49-F238E27FC236}">
+                <a16:creationId xmlns:a16="http://schemas.microsoft.com/office/drawing/2014/main" id="{FA015A4C-7A0F-44BE-AD1A-1804E17EEFF9}"/>
+              </a:ext>
+            </a:extLst>
+          </p:cNvPr>
+          <p:cNvPicPr>
+            <a:picLocks noChangeAspect="1"/>
+          </p:cNvPicPr>
+          <p:nvPr/>
+        </p:nvPicPr>
+        <p:blipFill>
+          <a:blip r:embed="rId4">
+            <a:extLst>
+              <a:ext uri="{28A0092B-C50C-407E-A947-70E740481C1C}">
+                <a14:useLocalDpi xmlns:a14="http://schemas.microsoft.com/office/drawing/2010/main" val="0"/>
+              </a:ext>
+            </a:extLst>
+          </a:blip>
+          <a:stretch>
+            <a:fillRect/>
+          </a:stretch>
+        </p:blipFill>
+        <p:spPr>
+          <a:xfrm>
+            <a:off x="639611" y="6078536"/>
+            <a:ext cx="484189" cy="484189"/>
+          </a:xfrm>
+          <a:prstGeom prst="rect">
+            <a:avLst/>
+          </a:prstGeom>
+        </p:spPr>
+      </p:pic>
+      <p:pic>
+        <p:nvPicPr>
+          <p:cNvPr id="13" name="Imagem 12">
+            <a:extLst>
+              <a:ext uri="{FF2B5EF4-FFF2-40B4-BE49-F238E27FC236}">
+                <a16:creationId xmlns:a16="http://schemas.microsoft.com/office/drawing/2014/main" id="{D2BA8251-41DB-4D7B-8633-FF42A9EFF31B}"/>
+              </a:ext>
+            </a:extLst>
+          </p:cNvPr>
+          <p:cNvPicPr>
+            <a:picLocks noChangeAspect="1"/>
+          </p:cNvPicPr>
+          <p:nvPr/>
+        </p:nvPicPr>
+        <p:blipFill>
+          <a:blip r:embed="rId5">
+            <a:extLst>
+              <a:ext uri="{28A0092B-C50C-407E-A947-70E740481C1C}">
+                <a14:useLocalDpi xmlns:a14="http://schemas.microsoft.com/office/drawing/2010/main" val="0"/>
+              </a:ext>
+            </a:extLst>
+          </a:blip>
+          <a:stretch>
+            <a:fillRect/>
+          </a:stretch>
+        </p:blipFill>
+        <p:spPr>
+          <a:xfrm>
+            <a:off x="611037" y="5334000"/>
+            <a:ext cx="522288" cy="522288"/>
           </a:xfrm>
           <a:prstGeom prst="rect">
             <a:avLst/>

</xml_diff>